<commit_message>
- Add exclusion of specific system placeholders from autofit. - Adjust body match criteria for placeholders with any index. - Add a test for autofit in two-column layouts.
</commit_message>
<xml_diff>
--- a/tests/output/badge.pptx
+++ b/tests/output/badge.pptx
@@ -8090,7 +8090,9 @@
         </p:nvSpPr>
         <p:spPr/>
         <p:txBody>
-          <a:bodyPr/>
+          <a:bodyPr>
+            <a:normAutofit/>
+          </a:bodyPr>
           <a:lstStyle/>
           <a:p>
             <a:pPr lvl="0"/>
@@ -9420,7 +9422,9 @@
         </p:nvSpPr>
         <p:spPr/>
         <p:txBody>
-          <a:bodyPr/>
+          <a:bodyPr>
+            <a:normAutofit/>
+          </a:bodyPr>
           <a:lstStyle/>
           <a:p>
             <a:pPr lvl="0"/>

</xml_diff>

<commit_message>
- Add a new method `balanceTwoColumnAnchor` to balance anchor alignment in slides. - Update tests to include check for `anchor="ctr"` when a picture is present. - Modify binary test output files to reflect changes in anchor alignment.
</commit_message>
<xml_diff>
--- a/tests/output/badge.pptx
+++ b/tests/output/badge.pptx
@@ -8090,7 +8090,7 @@
         </p:nvSpPr>
         <p:spPr/>
         <p:txBody>
-          <a:bodyPr>
+          <a:bodyPr anchor="ctr">
             <a:normAutofit/>
           </a:bodyPr>
           <a:lstStyle/>
@@ -9422,7 +9422,7 @@
         </p:nvSpPr>
         <p:spPr/>
         <p:txBody>
-          <a:bodyPr>
+          <a:bodyPr anchor="ctr">
             <a:normAutofit/>
           </a:bodyPr>
           <a:lstStyle/>
@@ -10081,7 +10081,7 @@
         </p:nvSpPr>
         <p:spPr/>
         <p:txBody>
-          <a:bodyPr>
+          <a:bodyPr anchor="ctr">
             <a:normAutofit/>
           </a:bodyPr>
           <a:lstStyle/>

</xml_diff>